<commit_message>
Presentation 3 - Finalized
</commit_message>
<xml_diff>
--- a/Presentations/semicolon - presentation 1.pptx
+++ b/Presentations/semicolon - presentation 1.pptx
@@ -302,7 +302,7 @@
           <a:p>
             <a:fld id="{5BE36176-F394-46B4-BC01-6E0C50BD9B29}" type="datetimeFigureOut">
               <a:rPr lang="en-CA" smtClean="0"/>
-              <a:t>2025-02-02</a:t>
+              <a:t>2025-03-31</a:t>
             </a:fld>
             <a:endParaRPr lang="en-CA"/>
           </a:p>
@@ -502,7 +502,7 @@
           <a:p>
             <a:fld id="{5BE36176-F394-46B4-BC01-6E0C50BD9B29}" type="datetimeFigureOut">
               <a:rPr lang="en-CA" smtClean="0"/>
-              <a:t>2025-02-02</a:t>
+              <a:t>2025-03-31</a:t>
             </a:fld>
             <a:endParaRPr lang="en-CA"/>
           </a:p>
@@ -712,7 +712,7 @@
           <a:p>
             <a:fld id="{5BE36176-F394-46B4-BC01-6E0C50BD9B29}" type="datetimeFigureOut">
               <a:rPr lang="en-CA" smtClean="0"/>
-              <a:t>2025-02-02</a:t>
+              <a:t>2025-03-31</a:t>
             </a:fld>
             <a:endParaRPr lang="en-CA"/>
           </a:p>
@@ -912,7 +912,7 @@
           <a:p>
             <a:fld id="{5BE36176-F394-46B4-BC01-6E0C50BD9B29}" type="datetimeFigureOut">
               <a:rPr lang="en-CA" smtClean="0"/>
-              <a:t>2025-02-02</a:t>
+              <a:t>2025-03-31</a:t>
             </a:fld>
             <a:endParaRPr lang="en-CA"/>
           </a:p>
@@ -1188,7 +1188,7 @@
           <a:p>
             <a:fld id="{5BE36176-F394-46B4-BC01-6E0C50BD9B29}" type="datetimeFigureOut">
               <a:rPr lang="en-CA" smtClean="0"/>
-              <a:t>2025-02-02</a:t>
+              <a:t>2025-03-31</a:t>
             </a:fld>
             <a:endParaRPr lang="en-CA"/>
           </a:p>
@@ -1456,7 +1456,7 @@
           <a:p>
             <a:fld id="{5BE36176-F394-46B4-BC01-6E0C50BD9B29}" type="datetimeFigureOut">
               <a:rPr lang="en-CA" smtClean="0"/>
-              <a:t>2025-02-02</a:t>
+              <a:t>2025-03-31</a:t>
             </a:fld>
             <a:endParaRPr lang="en-CA"/>
           </a:p>
@@ -1871,7 +1871,7 @@
           <a:p>
             <a:fld id="{5BE36176-F394-46B4-BC01-6E0C50BD9B29}" type="datetimeFigureOut">
               <a:rPr lang="en-CA" smtClean="0"/>
-              <a:t>2025-02-02</a:t>
+              <a:t>2025-03-31</a:t>
             </a:fld>
             <a:endParaRPr lang="en-CA"/>
           </a:p>
@@ -2013,7 +2013,7 @@
           <a:p>
             <a:fld id="{5BE36176-F394-46B4-BC01-6E0C50BD9B29}" type="datetimeFigureOut">
               <a:rPr lang="en-CA" smtClean="0"/>
-              <a:t>2025-02-02</a:t>
+              <a:t>2025-03-31</a:t>
             </a:fld>
             <a:endParaRPr lang="en-CA"/>
           </a:p>
@@ -2126,7 +2126,7 @@
           <a:p>
             <a:fld id="{5BE36176-F394-46B4-BC01-6E0C50BD9B29}" type="datetimeFigureOut">
               <a:rPr lang="en-CA" smtClean="0"/>
-              <a:t>2025-02-02</a:t>
+              <a:t>2025-03-31</a:t>
             </a:fld>
             <a:endParaRPr lang="en-CA"/>
           </a:p>
@@ -2439,7 +2439,7 @@
           <a:p>
             <a:fld id="{5BE36176-F394-46B4-BC01-6E0C50BD9B29}" type="datetimeFigureOut">
               <a:rPr lang="en-CA" smtClean="0"/>
-              <a:t>2025-02-02</a:t>
+              <a:t>2025-03-31</a:t>
             </a:fld>
             <a:endParaRPr lang="en-CA"/>
           </a:p>
@@ -2728,7 +2728,7 @@
           <a:p>
             <a:fld id="{5BE36176-F394-46B4-BC01-6E0C50BD9B29}" type="datetimeFigureOut">
               <a:rPr lang="en-CA" smtClean="0"/>
-              <a:t>2025-02-02</a:t>
+              <a:t>2025-03-31</a:t>
             </a:fld>
             <a:endParaRPr lang="en-CA"/>
           </a:p>
@@ -2971,7 +2971,7 @@
           <a:p>
             <a:fld id="{5BE36176-F394-46B4-BC01-6E0C50BD9B29}" type="datetimeFigureOut">
               <a:rPr lang="en-CA" smtClean="0"/>
-              <a:t>2025-02-02</a:t>
+              <a:t>2025-03-31</a:t>
             </a:fld>
             <a:endParaRPr lang="en-CA"/>
           </a:p>
@@ -21064,7 +21064,7 @@
                 <a:ea typeface="Noto Sans SC" panose="020B0200000000000000" pitchFamily="34" charset="-128"/>
                 <a:cs typeface="Poppins" panose="00000500000000000000" pitchFamily="2" charset="0"/>
               </a:rPr>
-              <a:t>Get client feedback on current prototype.</a:t>
+              <a:t>Get client feedback on current presentation and prototype.</a:t>
             </a:r>
           </a:p>
           <a:p>
@@ -21089,7 +21089,7 @@
                 <a:ea typeface="Noto Sans SC" panose="020B0200000000000000" pitchFamily="34" charset="-128"/>
                 <a:cs typeface="Poppins" panose="00000500000000000000" pitchFamily="2" charset="0"/>
               </a:rPr>
-              <a:t>Work closely to client requirements and current feedback, toward to the next prototype.</a:t>
+              <a:t>Implement final feedback adjustments and any bug fixes.</a:t>
             </a:r>
           </a:p>
           <a:p>
@@ -21114,32 +21114,7 @@
                 <a:ea typeface="Noto Sans SC" panose="020B0200000000000000" pitchFamily="34" charset="-128"/>
                 <a:cs typeface="Poppins" panose="00000500000000000000" pitchFamily="2" charset="0"/>
               </a:rPr>
-              <a:t>Develop the Volunteer Management system into the current web application.</a:t>
-            </a:r>
-          </a:p>
-          <a:p>
-            <a:pPr marL="457200" indent="-457200">
-              <a:buFont typeface="Arial" panose="020B0604020202020204" pitchFamily="34" charset="0"/>
-              <a:buChar char="•"/>
-            </a:pPr>
-            <a:endParaRPr lang="en-CA" sz="2000" dirty="0">
-              <a:latin typeface="Poppins" panose="00000500000000000000" pitchFamily="2" charset="0"/>
-              <a:ea typeface="Noto Sans SC" panose="020B0200000000000000" pitchFamily="34" charset="-128"/>
-              <a:cs typeface="Poppins" panose="00000500000000000000" pitchFamily="2" charset="0"/>
-            </a:endParaRPr>
-          </a:p>
-          <a:p>
-            <a:pPr marL="457200" indent="-457200">
-              <a:buFont typeface="Arial" panose="020B0604020202020204" pitchFamily="34" charset="0"/>
-              <a:buChar char="•"/>
-            </a:pPr>
-            <a:r>
-              <a:rPr lang="en-CA" sz="2000" dirty="0">
-                <a:latin typeface="Poppins" panose="00000500000000000000" pitchFamily="2" charset="0"/>
-                <a:ea typeface="Noto Sans SC" panose="020B0200000000000000" pitchFamily="34" charset="-128"/>
-                <a:cs typeface="Poppins" panose="00000500000000000000" pitchFamily="2" charset="0"/>
-              </a:rPr>
-              <a:t>Implement branding and refresh to the interface (UI/UX) of the web application.</a:t>
+              <a:t>Move forward with the project finalization.</a:t>
             </a:r>
           </a:p>
         </p:txBody>

</xml_diff>